<commit_message>
Ajoute le complément anglais The past simple in boxes (phrases +, −, ? découpées en cases)
n't est désormais collé à did / has dans les découpes des trois decks anglais.

Co-Authored-By: Claude Opus 5.5 <noreply@anthropic.com>
Claude-Session: https://claude.ai/code/session_01GHo9GbchfMk8JhTz1kwo92
</commit_message>
<xml_diff>
--- a/anglais_grammaire/powerpoints/English_Past_simple.pptx
+++ b/anglais_grammaire/powerpoints/English_Past_simple.pptx
@@ -143,12 +143,12 @@
   <p:extLst>
     <p:ext uri="{521415D9-36F7-43E2-AB2F-B90AF26B5E84}">
       <p14:sectionLst xmlns:p14="http://schemas.microsoft.com/office/powerpoint/2010/main">
-        <p14:section name="Opening" id="{0ac254bc-42e7-3fc8-e53f-d15e570264af}">
+        <p14:section name="Opening" id="{f4c6811c-27f2-cd1f-1d69-b70457a8411e}">
           <p14:sldIdLst>
             <p14:sldId id="256"/>
           </p14:sldIdLst>
         </p14:section>
-        <p14:section name="Discover" id="{ca476204-e165-40d2-fbe8-bb3d3af64d1f}">
+        <p14:section name="Discover" id="{706016fa-6ed1-f06f-8afe-49b42f0c9895}">
           <p14:sldIdLst>
             <p14:sldId id="257"/>
             <p14:sldId id="258"/>
@@ -158,21 +158,21 @@
             <p14:sldId id="262"/>
           </p14:sldIdLst>
         </p14:section>
-        <p14:section name="Irregular verbs" id="{726818c6-4376-ec58-acbf-bc7ccc8be907}">
+        <p14:section name="Irregular verbs" id="{7102338f-fbcd-d750-3d02-bc11b6c27498}">
           <p14:sldIdLst>
             <p14:sldId id="263"/>
             <p14:sldId id="264"/>
             <p14:sldId id="265"/>
           </p14:sldIdLst>
         </p14:section>
-        <p14:section name="Negative and questions" id="{4be5d5c6-fe1e-bcbf-2484-e10e7b565a56}">
+        <p14:section name="Negative and questions" id="{bd71f851-6e26-9d10-34ba-39f9c7ed843f}">
           <p14:sldIdLst>
             <p14:sldId id="266"/>
             <p14:sldId id="267"/>
             <p14:sldId id="268"/>
           </p14:sldIdLst>
         </p14:section>
-        <p14:section name="Telling stories" id="{1768bd77-da89-3b32-1c0f-7d8aa2c62e50}">
+        <p14:section name="Telling stories" id="{957dd6fe-19d0-2cb1-c013-a1cc8bfe55ee}">
           <p14:sldIdLst>
             <p14:sldId id="269"/>
             <p14:sldId id="270"/>
@@ -180,7 +180,7 @@
             <p14:sldId id="272"/>
           </p14:sldIdLst>
         </p14:section>
-        <p14:section name="YOUR TURN! — Exercises" id="{d978a4eb-ffc2-3289-17bd-47d7dfaa18ab}">
+        <p14:section name="YOUR TURN! — Exercises" id="{fb5feda1-a43a-78a3-9e12-5990d780bece}">
           <p14:sldIdLst>
             <p14:sldId id="273"/>
             <p14:sldId id="274"/>
@@ -203,7 +203,7 @@
             <p14:sldId id="291"/>
           </p14:sldIdLst>
         </p14:section>
-        <p14:section name="Closing" id="{8cf4c73c-6766-856c-60ed-b5b0fe2d7b20}">
+        <p14:section name="Closing" id="{42e86e6d-8d58-d7ed-5179-774c2385bba0}">
           <p14:sldIdLst>
             <p14:sldId id="292"/>
           </p14:sldIdLst>
@@ -7881,8 +7881,8 @@
         </p:nvSpPr>
         <p:spPr>
           <a:xfrm>
-            <a:off x="2752139" y="2971800"/>
-            <a:ext cx="928094" cy="640080"/>
+            <a:off x="2697275" y="2971800"/>
+            <a:ext cx="818366" cy="640080"/>
           </a:xfrm>
           <a:prstGeom prst="roundRect">
             <a:avLst>
@@ -7910,8 +7910,8 @@
         </p:nvSpPr>
         <p:spPr>
           <a:xfrm>
-            <a:off x="2752139" y="2971800"/>
-            <a:ext cx="928094" cy="640080"/>
+            <a:off x="2697275" y="2971800"/>
+            <a:ext cx="818366" cy="640080"/>
           </a:xfrm>
           <a:prstGeom prst="rect">
             <a:avLst/>
@@ -7946,8 +7946,8 @@
         </p:nvSpPr>
         <p:spPr>
           <a:xfrm>
-            <a:off x="2432099" y="3648456"/>
-            <a:ext cx="1568174" cy="274320"/>
+            <a:off x="2377235" y="3648456"/>
+            <a:ext cx="1458446" cy="274320"/>
           </a:xfrm>
           <a:prstGeom prst="rect">
             <a:avLst/>
@@ -7982,7 +7982,7 @@
         </p:nvSpPr>
         <p:spPr>
           <a:xfrm>
-            <a:off x="3753385" y="2971800"/>
+            <a:off x="3588793" y="2971800"/>
             <a:ext cx="1279575" cy="640080"/>
           </a:xfrm>
           <a:prstGeom prst="roundRect">
@@ -8009,7 +8009,7 @@
         </p:nvSpPr>
         <p:spPr>
           <a:xfrm>
-            <a:off x="3753385" y="2971800"/>
+            <a:off x="3588793" y="2971800"/>
             <a:ext cx="1279575" cy="640080"/>
           </a:xfrm>
           <a:prstGeom prst="rect">
@@ -8045,7 +8045,7 @@
         </p:nvSpPr>
         <p:spPr>
           <a:xfrm>
-            <a:off x="3433345" y="3648456"/>
+            <a:off x="3268753" y="3648456"/>
             <a:ext cx="1919655" cy="274320"/>
           </a:xfrm>
           <a:prstGeom prst="rect">
@@ -8081,7 +8081,7 @@
         </p:nvSpPr>
         <p:spPr>
           <a:xfrm>
-            <a:off x="5106112" y="2971800"/>
+            <a:off x="4941520" y="2971800"/>
             <a:ext cx="2803185" cy="640080"/>
           </a:xfrm>
           <a:prstGeom prst="roundRect">
@@ -8108,7 +8108,7 @@
         </p:nvSpPr>
         <p:spPr>
           <a:xfrm>
-            <a:off x="5106112" y="2971800"/>
+            <a:off x="4941520" y="2971800"/>
             <a:ext cx="2803185" cy="640080"/>
           </a:xfrm>
           <a:prstGeom prst="rect">

</xml_diff>